<commit_message>
[pptx-compose-xazv] Relabel stale localized fixtures
</commit_message>
<xml_diff>
--- a/fixtures/real-world/rsm-technology-strategy-de.pptx
+++ b/fixtures/real-world/rsm-technology-strategy-de.pptx
@@ -1715,7 +1715,7 @@
         <a:p>
           <a:r>
             <a:rPr lang="en-GB" sz="1100" b="1" dirty="0" smtClean="0"/>
-            <a:t>DE: RSM Technology Consulting</a:t>
+            <a:t>RSM Technology Consulting</a:t>
           </a:r>
           <a:endParaRPr lang="en-GB" sz="1100" b="1" dirty="0"/>
         </a:p>
@@ -1752,7 +1752,7 @@
         <a:p>
           <a:r>
             <a:rPr lang="en-GB" sz="1100" b="1" dirty="0" smtClean="0"/>
-            <a:t>DE: Digital  IT strategy</a:t>
+            <a:t>Digital- und IT-Strategie</a:t>
           </a:r>
           <a:endParaRPr lang="en-GB" sz="1100" b="1" dirty="0"/>
         </a:p>
@@ -1789,7 +1789,7 @@
         <a:p>
           <a:r>
             <a:rPr lang="en-GB" sz="1100" b="1" dirty="0" smtClean="0"/>
-            <a:t>DE: ERP  accounting systems</a:t>
+            <a:t>ERP- und Buchhaltungssysteme</a:t>
           </a:r>
           <a:endParaRPr lang="en-GB" sz="1100" b="1" dirty="0"/>
         </a:p>
@@ -1830,7 +1830,7 @@
               <a:ea typeface="+mn-ea"/>
               <a:cs typeface="+mn-cs"/>
             </a:rPr>
-            <a:t>DE: IT risk</a:t>
+            <a:t>IT-Risiko</a:t>
           </a:r>
           <a:br>
             <a:rPr lang="en-GB" sz="1100" b="1" smtClean="0">
@@ -1845,7 +1845,7 @@
               <a:ea typeface="+mn-ea"/>
               <a:cs typeface="+mn-cs"/>
             </a:rPr>
-            <a:t>DE: and</a:t>
+            <a:t>und</a:t>
           </a:r>
           <a:br>
             <a:rPr lang="en-GB" sz="1100" b="1" smtClean="0">
@@ -1860,7 +1860,7 @@
               <a:ea typeface="+mn-ea"/>
               <a:cs typeface="+mn-cs"/>
             </a:rPr>
-            <a:t>DE: security</a:t>
+            <a:t>Sicherheit</a:t>
           </a:r>
           <a:endParaRPr lang="en-GB" sz="1100" b="1" dirty="0"/>
         </a:p>
@@ -1897,7 +1897,7 @@
         <a:p>
           <a:r>
             <a:rPr lang="en-GB" sz="1100" b="1" dirty="0" smtClean="0"/>
-            <a:t>DE: IT resilience</a:t>
+            <a:t>IT-Resilienz</a:t>
           </a:r>
           <a:endParaRPr lang="en-GB" sz="1100" b="1" dirty="0"/>
         </a:p>
@@ -1934,7 +1934,7 @@
         <a:p>
           <a:r>
             <a:rPr lang="en-GB" sz="1100" b="1" dirty="0" smtClean="0"/>
-            <a:t>DE: System selection</a:t>
+            <a:t>Systemauswahl</a:t>
           </a:r>
           <a:endParaRPr lang="en-GB" sz="1100" b="1" dirty="0"/>
         </a:p>
@@ -1971,7 +1971,7 @@
         <a:p>
           <a:r>
             <a:rPr lang="en-GB" sz="1100" b="1" dirty="0" smtClean="0"/>
-            <a:t>DE: IT project delivery</a:t>
+            <a:t>IT-Projektumsetzung</a:t>
           </a:r>
           <a:endParaRPr lang="en-GB" sz="1100" b="1" dirty="0"/>
         </a:p>
@@ -2351,7 +2351,7 @@
         <a:p>
           <a:r>
             <a:rPr lang="en-GB" dirty="0" smtClean="0"/>
-            <a:t>DE: Create a Digital Vision</a:t>
+            <a:t>Eine digitale Vision schaffen</a:t>
           </a:r>
           <a:endParaRPr lang="en-GB" dirty="0"/>
         </a:p>
@@ -2388,7 +2388,7 @@
         <a:p>
           <a:r>
             <a:rPr lang="en-GB" dirty="0" smtClean="0"/>
-            <a:t>DE: Establish clear leadership</a:t>
+            <a:t>Klare Führung etablieren</a:t>
           </a:r>
           <a:endParaRPr lang="en-GB" dirty="0"/>
         </a:p>
@@ -2425,7 +2425,7 @@
         <a:p>
           <a:r>
             <a:rPr lang="en-GB" dirty="0" smtClean="0"/>
-            <a:t>DE: Adopt a Continuous Improvement culture</a:t>
+            <a:t>Eine Kultur der kontinuierlichen Verbesserung etablieren</a:t>
           </a:r>
           <a:endParaRPr lang="en-GB" dirty="0"/>
         </a:p>
@@ -2462,7 +2462,7 @@
         <a:p>
           <a:r>
             <a:rPr lang="en-GB" sz="1000" dirty="0" smtClean="0"/>
-            <a:t>DE: Feedback and learning is key in digital transformation. As the organisation transforms, new opportunities will present themselves and an appropriate culture of continuous improvement is required, with staff acquiring new skills.</a:t>
+            <a:t>Feedback und Lernen sind in der digitalen Transformation entscheidend. Während sich die Organisation wandelt, ergeben sich neue Chancen, und es ist eine geeignete Kultur der kontinuierlichen Verbesserung erforderlich, in der die Mitarbeitenden neue Kompetenzen erwerben.</a:t>
           </a:r>
           <a:endParaRPr lang="en-GB" sz="1000" dirty="0"/>
         </a:p>
@@ -2499,7 +2499,7 @@
         <a:p>
           <a:r>
             <a:rPr lang="en-GB" dirty="0" smtClean="0"/>
-            <a:t>DE: Select appropriate digital technologies</a:t>
+            <a:t>Geeignete digitale Technologien auswählen</a:t>
           </a:r>
           <a:endParaRPr lang="en-GB" dirty="0"/>
         </a:p>
@@ -2536,7 +2536,7 @@
         <a:p>
           <a:r>
             <a:rPr lang="en-GB" sz="1000" dirty="0" smtClean="0"/>
-            <a:t>DE:  Create a clear vision for how digital technology can support and drive the organisation’s corporate strategy.  This requires an understanding of the potential of new technology combined with a clearly defined commercial strategy</a:t>
+            <a:t>Eine klare Vision dafür schaffen, wie digitale Technologie die Unternehmensstrategie der Organisation unterstützen und vorantreiben kann. Dies erfordert ein Verständnis des Potenzials neuer Technologien in Verbindung mit einer klar definierten Geschäftsstrategie.</a:t>
           </a:r>
           <a:endParaRPr lang="en-GB" sz="1000" dirty="0"/>
         </a:p>
@@ -2573,7 +2573,7 @@
         <a:p>
           <a:r>
             <a:rPr lang="en-GB" sz="1000" dirty="0" smtClean="0"/>
-            <a:t>DE: For digital transformation to succeed it requires full commitment from senior management across all functions.  Therefore there has to be a clear and agreed vision that transcends departmental boundaries, with a clear sponsorship structure for digital initiatives</a:t>
+            <a:t>Damit die digitale Transformation gelingt, ist das volle Engagement des oberen Managements über alle Funktionen hinweg erforderlich. Daher muss es eine klare und abgestimmte Vision geben, die Abteilungsgrenzen überschreitet, mit einer klaren Sponsoringstruktur für digitale Initiativen.</a:t>
           </a:r>
           <a:endParaRPr lang="en-GB" sz="1000" dirty="0"/>
         </a:p>
@@ -2610,7 +2610,7 @@
         <a:p>
           <a:r>
             <a:rPr lang="en-GB" sz="1000" dirty="0" smtClean="0"/>
-            <a:t>DE: Our experience tells us that the best approach to digital change is to avoid dismissing early ideas in order to generate a long-list of digital initiatives, which can then be evaluated against the Digital Vision</a:t>
+            <a:t>Unsere Erfahrung zeigt, dass der beste Ansatz für digitalen Wandel darin besteht, frühe Ideen nicht vorschnell zu verwerfen, um eine lange Liste digitaler Initiativen zu erstellen, die dann an der digitalen Vision gemessen werden können.</a:t>
           </a:r>
           <a:endParaRPr lang="en-GB" sz="1000" dirty="0"/>
         </a:p>
@@ -2647,7 +2647,7 @@
         <a:p>
           <a:r>
             <a:rPr lang="en-GB" dirty="0" smtClean="0"/>
-            <a:t>DE: Build momentum</a:t>
+            <a:t>Momentum aufbauen</a:t>
           </a:r>
           <a:endParaRPr lang="en-GB" dirty="0"/>
         </a:p>
@@ -2684,7 +2684,7 @@
         <a:p>
           <a:r>
             <a:rPr lang="en-GB" sz="1000" dirty="0" smtClean="0"/>
-            <a:t>DE: No organisation can do everything at once.  It is vital to be realistic with digital transformation, starting with quick wins and building momentum to drive the transformation forward. </a:t>
+            <a:t>Keine Organisation kann alles auf einmal tun. Es ist entscheidend, bei der digitalen Transformation realistisch zu sein, mit schnellen Erfolgen zu beginnen und Momentum aufzubauen, um die Transformation voranzutreiben.</a:t>
           </a:r>
           <a:endParaRPr lang="en-GB" sz="1000" dirty="0"/>
         </a:p>
@@ -3225,7 +3225,7 @@
           </a:pPr>
           <a:r>
             <a:rPr lang="en-GB" sz="1100" b="1" kern="1200" dirty="0" smtClean="0"/>
-            <a:t>Digital &amp; IT strategy</a:t>
+            <a:t>Digital- und IT-Strategie</a:t>
           </a:r>
           <a:endParaRPr lang="en-GB" sz="1100" b="1" kern="1200" dirty="0"/>
         </a:p>
@@ -3355,7 +3355,7 @@
           </a:pPr>
           <a:r>
             <a:rPr lang="en-GB" sz="1100" b="1" kern="1200" dirty="0" smtClean="0"/>
-            <a:t>System selection</a:t>
+            <a:t>ERP- und Buchhaltungssysteme</a:t>
           </a:r>
           <a:endParaRPr lang="en-GB" sz="1100" b="1" kern="1200" dirty="0"/>
         </a:p>
@@ -3485,7 +3485,7 @@
           </a:pPr>
           <a:r>
             <a:rPr lang="en-GB" sz="1100" b="1" kern="1200" dirty="0" smtClean="0"/>
-            <a:t>ERP &amp; accounting systems</a:t>
+            <a:t>IT-Risiko</a:t>
           </a:r>
           <a:endParaRPr lang="en-GB" sz="1100" b="1" kern="1200" dirty="0"/>
         </a:p>
@@ -3615,7 +3615,7 @@
           </a:pPr>
           <a:r>
             <a:rPr lang="en-GB" sz="1100" b="1" kern="1200" dirty="0" smtClean="0"/>
-            <a:t>IT project delivery</a:t>
+            <a:t>IT-Resilienz</a:t>
           </a:r>
           <a:endParaRPr lang="en-GB" sz="1100" b="1" kern="1200" dirty="0"/>
         </a:p>
@@ -3752,7 +3752,7 @@
               <a:ea typeface="+mn-ea"/>
               <a:cs typeface="+mn-cs"/>
             </a:rPr>
-            <a:t>IT risk</a:t>
+            <a:t>Systemauswahl</a:t>
           </a:r>
           <a:br>
             <a:rPr lang="en-GB" sz="1100" b="1" kern="1200" smtClean="0">
@@ -3862,7 +3862,7 @@
           </a:pPr>
           <a:r>
             <a:rPr lang="en-GB" sz="1100" b="1" kern="1200" dirty="0" smtClean="0"/>
-            <a:t>IT resilience</a:t>
+            <a:t>IT-Projektumsetzung</a:t>
           </a:r>
           <a:endParaRPr lang="en-GB" sz="1100" b="1" kern="1200" dirty="0"/>
         </a:p>
@@ -3961,7 +3961,7 @@
           </a:pPr>
           <a:r>
             <a:rPr lang="en-GB" sz="1000" kern="1200" dirty="0" smtClean="0"/>
-            <a:t> Create a clear vision for how digital technology can support and drive the organisation’s corporate strategy.  This requires an understanding of the potential of new technology combined with a clearly defined commercial strategy</a:t>
+            <a:t>Eine digitale Vision schaffen</a:t>
           </a:r>
           <a:endParaRPr lang="en-GB" sz="1000" kern="1200" dirty="0"/>
         </a:p>
@@ -4038,7 +4038,7 @@
           </a:pPr>
           <a:r>
             <a:rPr lang="en-GB" sz="1100" kern="1200" dirty="0" smtClean="0"/>
-            <a:t>Create a Digital Vision</a:t>
+            <a:t>Klare Führung etablieren</a:t>
           </a:r>
           <a:endParaRPr lang="en-GB" sz="1100" kern="1200" dirty="0"/>
         </a:p>
@@ -4125,7 +4125,7 @@
           </a:pPr>
           <a:r>
             <a:rPr lang="en-GB" sz="1000" kern="1200" dirty="0" smtClean="0"/>
-            <a:t>For digital transformation to succeed it requires full commitment from senior management across all functions.  Therefore there has to be a clear and agreed vision that transcends departmental boundaries, with a clear sponsorship structure for digital initiatives</a:t>
+            <a:t>Eine Kultur der kontinuierlichen Verbesserung etablieren</a:t>
           </a:r>
           <a:endParaRPr lang="en-GB" sz="1000" kern="1200" dirty="0"/>
         </a:p>
@@ -4202,7 +4202,7 @@
           </a:pPr>
           <a:r>
             <a:rPr lang="en-GB" sz="1100" kern="1200" dirty="0" smtClean="0"/>
-            <a:t>Establish clear leadership</a:t>
+            <a:t>Feedback und Lernen sind in der digitalen Transformation entscheidend. Während sich die Organisation wandelt, ergeben sich neue Chancen, und es ist eine geeignete Kultur der kontinuierlichen Verbesserung erforderlich, in der die Mitarbeitenden neue Kompetenzen erwerben.</a:t>
           </a:r>
           <a:endParaRPr lang="en-GB" sz="1100" kern="1200" dirty="0"/>
         </a:p>
@@ -4289,7 +4289,7 @@
           </a:pPr>
           <a:r>
             <a:rPr lang="en-GB" sz="1000" kern="1200" dirty="0" smtClean="0"/>
-            <a:t>Our experience tells us that the best approach to digital change is to avoid dismissing early ideas in order to generate a long-list of digital initiatives, which can then be evaluated against the Digital Vision</a:t>
+            <a:t>Geeignete digitale Technologien auswählen</a:t>
           </a:r>
           <a:endParaRPr lang="en-GB" sz="1000" kern="1200" dirty="0"/>
         </a:p>
@@ -4366,7 +4366,7 @@
           </a:pPr>
           <a:r>
             <a:rPr lang="en-GB" sz="1100" kern="1200" dirty="0" smtClean="0"/>
-            <a:t>Select appropriate digital technologies</a:t>
+            <a:t>Eine klare Vision dafür schaffen, wie digitale Technologie die Unternehmensstrategie der Organisation unterstützen und vorantreiben kann. Dies erfordert ein Verständnis des Potenzials neuer Technologien in Verbindung mit einer klar definierten Geschäftsstrategie.</a:t>
           </a:r>
           <a:endParaRPr lang="en-GB" sz="1100" kern="1200" dirty="0"/>
         </a:p>
@@ -4453,7 +4453,7 @@
           </a:pPr>
           <a:r>
             <a:rPr lang="en-GB" sz="1000" kern="1200" dirty="0" smtClean="0"/>
-            <a:t>No organisation can do everything at once.  It is vital to be realistic with digital transformation, starting with quick wins and building momentum to drive the transformation forward. </a:t>
+            <a:t>Damit die digitale Transformation gelingt, ist das volle Engagement des oberen Managements über alle Funktionen hinweg erforderlich. Daher muss es eine klare und abgestimmte Vision geben, die Abteilungsgrenzen überschreitet, mit einer klaren Sponsoringstruktur für digitale Initiativen.</a:t>
           </a:r>
           <a:endParaRPr lang="en-GB" sz="1000" kern="1200" dirty="0"/>
         </a:p>
@@ -4530,7 +4530,7 @@
           </a:pPr>
           <a:r>
             <a:rPr lang="en-GB" sz="1100" kern="1200" dirty="0" smtClean="0"/>
-            <a:t>Build momentum</a:t>
+            <a:t>Unsere Erfahrung zeigt, dass der beste Ansatz für digitalen Wandel darin besteht, frühe Ideen nicht vorschnell zu verwerfen, um eine lange Liste digitaler Initiativen zu erstellen, die dann an der digitalen Vision gemessen werden können.</a:t>
           </a:r>
           <a:endParaRPr lang="en-GB" sz="1100" kern="1200" dirty="0"/>
         </a:p>
@@ -4617,7 +4617,7 @@
           </a:pPr>
           <a:r>
             <a:rPr lang="en-GB" sz="1000" kern="1200" dirty="0" smtClean="0"/>
-            <a:t>Feedback and learning is key in digital transformation. As the organisation transforms, new opportunities will present themselves and an appropriate culture of continuous improvement is required, with staff acquiring new skills.</a:t>
+            <a:t>Momentum aufbauen</a:t>
           </a:r>
           <a:endParaRPr lang="en-GB" sz="1000" kern="1200" dirty="0"/>
         </a:p>
@@ -4694,7 +4694,7 @@
           </a:pPr>
           <a:r>
             <a:rPr lang="en-GB" sz="1100" kern="1200" dirty="0" smtClean="0"/>
-            <a:t>Adopt a Continuous Improvement culture</a:t>
+            <a:t>Keine Organisation kann alles auf einmal tun. Es ist entscheidend, bei der digitalen Transformation realistisch zu sein, mit schnellen Erfolgen zu beginnen und Momentum aufzubauen, um die Transformation voranzutreiben.</a:t>
           </a:r>
           <a:endParaRPr lang="en-GB" sz="1100" kern="1200" dirty="0"/>
         </a:p>
@@ -17411,9 +17411,8 @@
           <a:p>
             <a:r>
               <a:rPr lang="en-GB" dirty="0" smtClean="0"/>
-              <a:t>Wie man die digitale Transformation angeht</a:t>
+              <a:t>Wie man digitale Transformation angeht</a:t>
             </a:r>
-            <a:endParaRPr lang="en-GB" dirty="0"/>
           </a:p>
         </p:txBody>
       </p:sp>
@@ -17439,18 +17438,9 @@
           </a:bodyPr>
           <a:lstStyle/>
           <a:p>
-            <a:pPr marL="0" indent="0">
-              <a:spcBef>
-                <a:spcPts val="600"/>
-              </a:spcBef>
-              <a:spcAft>
-                <a:spcPts val="600"/>
-              </a:spcAft>
-              <a:buNone/>
-            </a:pPr>
             <a:r>
               <a:rPr lang="en-US" sz="1200" b="1" dirty="0" smtClean="0"/>
-              <a:t>Aus unserer Erfahrung mit der digitalen Transformation sind die folgenden Faktoren entscheidend für den Erfolg:</a:t>
+              <a:t>Aus unserer Erfahrung mit digitaler Transformation sind die folgenden Faktoren entscheidend für den Erfolg:</a:t>
             </a:r>
           </a:p>
         </p:txBody>
@@ -17584,44 +17574,14 @@
           </a:bodyPr>
           <a:lstStyle/>
           <a:p>
-            <a:pPr algn="ctr"/>
             <a:r>
               <a:rPr lang="en-GB" sz="2400" baseline="30000" dirty="0">
                 <a:solidFill>
                   <a:schemeClr val="bg1"/>
                 </a:solidFill>
               </a:rPr>
-              <a:t>Zusammenarbeit. Verständnis. </a:t>
+              <a:t>Zusammenarbeit. Verständnis. Ideen und Erkenntnisse.</a:t>
             </a:r>
-            <a:r>
-              <a:rPr lang="en-GB" sz="2400" baseline="30000" dirty="0" smtClean="0">
-                <a:solidFill>
-                  <a:schemeClr val="bg1"/>
-                </a:solidFill>
-              </a:rPr>
-              <a:t>Ideen </a:t>
-            </a:r>
-            <a:r>
-              <a:rPr lang="en-GB" sz="2400" baseline="30000" dirty="0">
-                <a:solidFill>
-                  <a:schemeClr val="bg1"/>
-                </a:solidFill>
-              </a:rPr>
-              <a:t>und Erkenntnisse</a:t>
-            </a:r>
-            <a:r>
-              <a:rPr lang="en-GB" sz="2400" baseline="30000" dirty="0" smtClean="0">
-                <a:solidFill>
-                  <a:schemeClr val="bg1"/>
-                </a:solidFill>
-              </a:rPr>
-              <a:t>.</a:t>
-            </a:r>
-            <a:endParaRPr lang="en-GB" sz="2400" baseline="30000" dirty="0">
-              <a:solidFill>
-                <a:schemeClr val="bg1"/>
-              </a:solidFill>
-            </a:endParaRPr>
           </a:p>
         </p:txBody>
       </p:sp>
@@ -17729,177 +17689,87 @@
                   <a:srgbClr val="63666A"/>
                 </a:solidFill>
               </a:rPr>
-              <a:t>RSM</a:t>
+              <a:t>RSM 25 Farringdon Street London EC4A 4AB</a:t>
             </a:r>
-            <a:br>
-              <a:rPr lang="de-DE" sz="1100" dirty="0">
-                <a:solidFill>
-                  <a:srgbClr val="63666A"/>
-                </a:solidFill>
-              </a:rPr>
-            </a:br>
+          </a:p>
+          <a:p>
             <a:r>
               <a:rPr lang="de-DE" sz="1100" dirty="0">
                 <a:solidFill>
                   <a:srgbClr val="63666A"/>
                 </a:solidFill>
               </a:rPr>
-              <a:t>25 Farringdon Street</a:t>
+              <a:t/>
             </a:r>
-            <a:br>
-              <a:rPr lang="de-DE" sz="1100" dirty="0">
-                <a:solidFill>
-                  <a:srgbClr val="63666A"/>
-                </a:solidFill>
-              </a:rPr>
-            </a:br>
+          </a:p>
+          <a:p>
             <a:r>
               <a:rPr lang="de-DE" sz="1100" dirty="0">
                 <a:solidFill>
                   <a:srgbClr val="63666A"/>
                 </a:solidFill>
               </a:rPr>
-              <a:t>London</a:t>
+              <a:t>rsmuk.com</a:t>
             </a:r>
-            <a:br>
-              <a:rPr lang="de-DE" sz="1100" dirty="0">
-                <a:solidFill>
-                  <a:srgbClr val="63666A"/>
-                </a:solidFill>
-              </a:rPr>
-            </a:br>
+          </a:p>
+          <a:p>
             <a:r>
               <a:rPr lang="de-DE" sz="1100" dirty="0">
                 <a:solidFill>
                   <a:srgbClr val="63666A"/>
                 </a:solidFill>
               </a:rPr>
-              <a:t>EC4A 4AB</a:t>
+              <a:t/>
             </a:r>
-            <a:endParaRPr lang="en-GB" sz="1100" dirty="0">
-              <a:solidFill>
-                <a:srgbClr val="63666A"/>
-              </a:solidFill>
-            </a:endParaRPr>
-          </a:p>
-          <a:p>
-            <a:endParaRPr lang="en-GB" sz="1400" b="1" dirty="0" smtClean="0">
-              <a:solidFill>
-                <a:srgbClr val="63666A"/>
-              </a:solidFill>
-            </a:endParaRPr>
           </a:p>
           <a:p>
             <a:r>
-              <a:rPr lang="en-GB" sz="1400" b="1" dirty="0" smtClean="0">
+              <a:rPr lang="de-DE" sz="1100" dirty="0">
                 <a:solidFill>
                   <a:srgbClr val="63666A"/>
                 </a:solidFill>
               </a:rPr>
-              <a:t>rsmuk.com</a:t>
+              <a:t>Die Gruppe von Unternehmen und LLPs im Vereinigten Königreich, die unter dem Namen RSM firmieren, ist Mitglied des RSM-Netzwerks. RSM ist der Handelsname, der von den Mitgliedern des RSM-Netzwerks verwendet wird. Jedes Mitglied des RSM-Netzwerks ist eine unabhängige Wirtschaftsprüfungs- und Beratungsgesellschaft, die jeweils im eigenen Namen tätig ist. Das RSM-Netzwerk ist selbst keine eigenständige juristische Person gleich welcher Art in irgendeiner Rechtsordnung. Das RSM-Netzwerk wird von RSM International Limited verwaltet, einer in England und Wales registrierten Gesellschaft (Handelsregisternummer 4040598) mit Sitz in 11 Old Jewry, London EC2R 8DU. Die Marke und das Warenzeichen RSM sowie andere von den Mitgliedern des Netzwerks genutzte geistige Eigentumsrechte sind Eigentum der RSM International Association, einer Vereinigung nach Artikel 60 ff. des Schweizerischen Zivilgesetzbuchs mit Sitz in Zug.</a:t>
             </a:r>
           </a:p>
           <a:p>
-            <a:endParaRPr lang="en-GB" sz="1400" b="1" dirty="0">
-              <a:solidFill>
-                <a:srgbClr val="63666A"/>
-              </a:solidFill>
-            </a:endParaRPr>
-          </a:p>
-          <a:p>
             <a:r>
-              <a:rPr lang="en-US" sz="1000" dirty="0" smtClean="0"/>
-              <a:t>Die </a:t>
-            </a:r>
-            <a:r>
-              <a:rPr lang="en-US" sz="1000" dirty="0"/>
-              <a:t>britische Unternehmensgruppe und LLPs, die unter dem Namen RSM tätig sind, ist Mitglied des RSM-Netzwerks. RSM ist der Handelsname, der von den Mitgliedern des RSM-Netzwerks verwendet wird. Jedes Mitglied des RSM-Netzwerks ist eine unabhängige Wirtschaftsprüfungs- und Beratungsgesellschaft, die jeweils </a:t>
-            </a:r>
-            <a:r>
-              <a:rPr lang="en-US" sz="1000" dirty="0" err="1"/>
-              <a:t>praktiziert</a:t>
-            </a:r>
-            <a:r>
-              <a:rPr lang="en-US" sz="1000" dirty="0"/>
-              <a:t> in eigenem Namen. Das RSM-Netzwerk ist selbst keine eigenständige juristische Person irgendeiner Art in irgendeiner Jurisdiktion. Das RSM-Netzwerk wird von RSM International Limited verwaltet, einer in England und Wales eingetragenen Gesellschaft (Gesellschaftsnummer 4040598) mit eingetragenem Sitz unter 11 Old Jewry, London EC2R 8DU. Die Marke und das Warenzeichen RSM sowie andere geistige Eigentumsrechte, die von Mitgliedern des Netzwerks genutzt werden, sind Eigentum der RSM International Association, einem Verein, der gemäß Artikel 60 et </a:t>
-            </a:r>
-            <a:r>
-              <a:rPr lang="en-US" sz="1000" dirty="0" err="1"/>
-              <a:t>seq</a:t>
-            </a:r>
-            <a:r>
-              <a:rPr lang="en-US" sz="1000" dirty="0"/>
-              <a:t> des Schweizerischen Zivilgesetzbuches mit Sitz in Zug geregelt wird.</a:t>
-            </a:r>
-          </a:p>
-          <a:p>
-            <a:endParaRPr lang="en-US" sz="1000" dirty="0"/>
-          </a:p>
-          <a:p>
-            <a:r>
-              <a:rPr lang="en-US" sz="1000" dirty="0"/>
-              <a:t>RSM UK Consulting LLP, RSM Corporate Finance LLP, RSM Restructuring Advisory LLP, RSM Risk Assurance Services LLP, RSM Tax and Advisory Services LLP, RSM UK Audit LLP und RSM UK Tax  and Accounting Limited sind nicht </a:t>
-            </a:r>
-            <a:r>
-              <a:rPr lang="en-US" sz="1000" dirty="0" err="1"/>
-              <a:t>zugelassen</a:t>
-            </a:r>
-            <a:r>
-              <a:rPr lang="en-US" sz="1000" dirty="0"/>
-              <a:t> gemäß dem Financial Services and Markets Act 2000, sind jedoch unter bestimmten Umständen in der Lage, ein begrenztes Spektrum an Investmentdienstleistungen anzubieten, da wir Mitglieder des Institute of Chartered Accountants in England and Wales sind.  Wir können diese Investmentdienstleistungen erbringen, sofern sie ein Nebenbestandteil der professionellen Dienstleistungen sind, mit deren Erbringung wir beauftragt wurden. Baker Tilly Creditor Services LLP ist </a:t>
-            </a:r>
-            <a:r>
-              <a:rPr lang="en-US" sz="1000" dirty="0" err="1"/>
-              <a:t>zugelassen</a:t>
-            </a:r>
-            <a:r>
-              <a:rPr lang="en-US" sz="1000" dirty="0"/>
-              <a:t> und reguliert von der Financial Conduct Authority für kreditbezogene regulierte Tätigkeiten. RSM  Co (UK) Limited ist </a:t>
-            </a:r>
-            <a:r>
-              <a:rPr lang="en-US" sz="1000" dirty="0" err="1"/>
-              <a:t>zugelassen</a:t>
-            </a:r>
-            <a:r>
-              <a:rPr lang="en-US" sz="1000" dirty="0"/>
-              <a:t> und reguliert von der Financial Conduct Authority zur Durchführung eines breiten Spektrums von Investmentgeschäfts</a:t>
-            </a:r>
-            <a:r>
-              <a:rPr lang="en-US" sz="1000" dirty="0" smtClean="0"/>
-              <a:t>tätigkeiten. </a:t>
-            </a:r>
-            <a:r>
-              <a:rPr lang="en-US" sz="1000" dirty="0"/>
-              <a:t>Obwohl alle Anstrengungen unternommen wurden, um Genauigkeit zu gewährleisten, ist die in dieser Mitteilung enthaltene Information möglicherweise nicht vollständig, und Empfänger sollten nicht ohne vorherige professionelle Beratung auf der Grundlage dieser Information handeln</a:t>
-            </a:r>
-            <a:r>
-              <a:rPr lang="en-US" sz="1000" dirty="0" smtClean="0"/>
-              <a:t>.</a:t>
-            </a:r>
-          </a:p>
-          <a:p>
-            <a:endParaRPr lang="en-US" sz="1000" dirty="0" smtClean="0"/>
-          </a:p>
-          <a:p>
-            <a:r>
-              <a:rPr lang="en-US" sz="1000" dirty="0" smtClean="0"/>
-              <a:t>© </a:t>
-            </a:r>
-            <a:r>
-              <a:rPr lang="en-US" sz="1000" dirty="0"/>
-              <a:t>2016 RSM UK Group LLP, alle Rechte </a:t>
-            </a:r>
-            <a:r>
-              <a:rPr lang="en-US" sz="1000" dirty="0" smtClean="0"/>
-              <a:t>vorbehalten</a:t>
-            </a:r>
-            <a:r>
-              <a:rPr lang="en-GB" sz="1000" dirty="0" smtClean="0">
+              <a:rPr lang="de-DE" sz="1100" dirty="0">
                 <a:solidFill>
                   <a:srgbClr val="63666A"/>
                 </a:solidFill>
               </a:rPr>
-              <a:t>.</a:t>
+              <a:t/>
+            </a:r>
+          </a:p>
+          <a:p>
+            <a:r>
+              <a:rPr lang="de-DE" sz="1100" dirty="0">
+                <a:solidFill>
+                  <a:srgbClr val="63666A"/>
+                </a:solidFill>
+              </a:rPr>
+              <a:t>RSM UK Consulting LLP, RSM Corporate Finance LLP, RSM Restructuring Advisory LLP, RSM Risk Assurance Services LLP, RSM Tax and Advisory Services LLP, RSM UK Audit LLP und RSM UK Tax and Accounting Limited sind nicht nach dem Financial Services and Markets Act 2000 zugelassen, wir sind jedoch unter bestimmten Umständen in der Lage, ein begrenztes Spektrum an Anlagedienstleistungen anzubieten, da wir Mitglieder des Institute of Chartered Accountants in England and Wales sind. Wir können diese Anlagedienstleistungen erbringen, wenn sie ein untergeordneter Bestandteil der von uns beauftragten professionellen Dienstleistungen sind. Baker Tilly Creditor Services LLP ist von der Financial Conduct Authority für kreditbezogene regulierte Tätigkeiten zugelassen und wird von dieser beaufsichtigt. RSM Co (UK) Limited ist von der Financial Conduct Authority zugelassen und wird von dieser beaufsichtigt, um ein Spektrum von Anlagegeschäften durchzuführen. Obwohl alle Anstrengungen unternommen wurden, um die Richtigkeit sicherzustellen, sind die in dieser Mitteilung enthaltenen Informationen möglicherweise nicht vollständig, und Empfänger sollten nicht ohne professionelle Beratung darauf vertrauen.</a:t>
+            </a:r>
+          </a:p>
+          <a:p>
+            <a:r>
+              <a:rPr lang="de-DE" sz="1100" dirty="0">
+                <a:solidFill>
+                  <a:srgbClr val="63666A"/>
+                </a:solidFill>
+              </a:rPr>
+              <a:t/>
+            </a:r>
+          </a:p>
+          <a:p>
+            <a:r>
+              <a:rPr lang="de-DE" sz="1100" dirty="0">
+                <a:solidFill>
+                  <a:srgbClr val="63666A"/>
+                </a:solidFill>
+              </a:rPr>
+              <a:t>© 2016 RSM UK Group LLP, alle Rechte vorbehalten.</a:t>
             </a:r>
           </a:p>
         </p:txBody>
@@ -18027,7 +17897,7 @@
                   <a:schemeClr val="accent2"/>
                 </a:solidFill>
               </a:rPr>
-              <a:t>Partner, Technologieberatung</a:t>
+              <a:t>Partner, Technology Consulting</a:t>
             </a:r>
           </a:p>
           <a:p>
@@ -18215,7 +18085,6 @@
               <a:rPr lang="en-GB" dirty="0" smtClean="0"/>
               <a:t>Was passiert da draußen?</a:t>
             </a:r>
-            <a:endParaRPr lang="en-GB" dirty="0"/>
           </a:p>
         </p:txBody>
       </p:sp>
@@ -18511,30 +18380,12 @@
           </a:bodyPr>
           <a:lstStyle/>
           <a:p>
-            <a:pPr algn="ctr">
-              <a:defRPr/>
-            </a:pPr>
             <a:r>
               <a:rPr lang="en-US" b="1" kern="0" dirty="0" smtClean="0">
                 <a:latin typeface="Calibri"/>
               </a:rPr>
-              <a:t>Big Data &amp; Analy</a:t>
+              <a:t>Big Data und Analytics</a:t>
             </a:r>
-            <a:r>
-              <a:rPr lang="en-US" b="1" kern="0" dirty="0" smtClean="0">
-                <a:solidFill>
-                  <a:sysClr val="windowText" lastClr="000000"/>
-                </a:solidFill>
-                <a:latin typeface="Calibri"/>
-              </a:rPr>
-              <a:t>tics</a:t>
-            </a:r>
-            <a:endParaRPr lang="en-US" b="1" kern="0" dirty="0">
-              <a:solidFill>
-                <a:sysClr val="windowText" lastClr="000000"/>
-              </a:solidFill>
-              <a:latin typeface="Calibri"/>
-            </a:endParaRPr>
           </a:p>
         </p:txBody>
       </p:sp>
@@ -18560,18 +18411,12 @@
           </a:bodyPr>
           <a:lstStyle/>
           <a:p>
-            <a:pPr>
-              <a:defRPr/>
-            </a:pPr>
             <a:r>
               <a:rPr lang="en-US" b="1" kern="0" dirty="0" smtClean="0">
                 <a:latin typeface="Calibri"/>
               </a:rPr>
               <a:t>Mobiles Arbeiten</a:t>
             </a:r>
-            <a:endParaRPr lang="en-US" b="1" kern="0" dirty="0">
-              <a:latin typeface="Calibri"/>
-            </a:endParaRPr>
           </a:p>
         </p:txBody>
       </p:sp>
@@ -18597,18 +18442,12 @@
           </a:bodyPr>
           <a:lstStyle/>
           <a:p>
-            <a:pPr algn="ctr">
-              <a:defRPr/>
-            </a:pPr>
             <a:r>
               <a:rPr lang="en-US" b="1" kern="0" dirty="0" smtClean="0">
                 <a:latin typeface="Calibri"/>
               </a:rPr>
               <a:t>Die Cloud</a:t>
             </a:r>
-            <a:endParaRPr lang="en-US" b="1" kern="0" dirty="0">
-              <a:latin typeface="Calibri"/>
-            </a:endParaRPr>
           </a:p>
         </p:txBody>
       </p:sp>
@@ -18634,18 +18473,12 @@
           </a:bodyPr>
           <a:lstStyle/>
           <a:p>
-            <a:pPr>
-              <a:defRPr/>
-            </a:pPr>
             <a:r>
               <a:rPr lang="en-US" b="1" kern="0" dirty="0" smtClean="0">
                 <a:latin typeface="Calibri"/>
               </a:rPr>
               <a:t>Soziale Medien</a:t>
             </a:r>
-            <a:endParaRPr lang="en-US" b="1" kern="0" dirty="0">
-              <a:latin typeface="Calibri"/>
-            </a:endParaRPr>
           </a:p>
         </p:txBody>
       </p:sp>
@@ -19223,23 +19056,6 @@
           </a:bodyPr>
           <a:lstStyle/>
           <a:p>
-            <a:pPr marL="266700" marR="0" lvl="0" indent="0" defTabSz="1019175" eaLnBrk="1" fontAlgn="base" latinLnBrk="0" hangingPunct="1">
-              <a:lnSpc>
-                <a:spcPct val="100000"/>
-              </a:lnSpc>
-              <a:spcBef>
-                <a:spcPts val="600"/>
-              </a:spcBef>
-              <a:spcAft>
-                <a:spcPts val="600"/>
-              </a:spcAft>
-              <a:buClrTx/>
-              <a:buSzTx/>
-              <a:buFontTx/>
-              <a:buNone/>
-              <a:tabLst/>
-              <a:defRPr/>
-            </a:pPr>
             <a:r>
               <a:rPr kumimoji="0" lang="en-GB" sz="1800" b="1" i="0" u="none" strike="noStrike" kern="0" cap="none" spc="0" normalizeH="0" baseline="0" noProof="0" dirty="0" smtClean="0">
                 <a:ln>
@@ -19255,29 +19071,12 @@
                 <a:ea typeface="+mn-ea"/>
                 <a:cs typeface="Arial" charset="0"/>
               </a:rPr>
-              <a:t>Wie kann ich Technologie nutzen, um...</a:t>
+              <a:t>Wie kann ich Technologie nutzen, um …</a:t>
             </a:r>
           </a:p>
           <a:p>
-            <a:pPr marL="285750" marR="0" lvl="0" indent="-285750" defTabSz="1019175" eaLnBrk="1" fontAlgn="base" latinLnBrk="0" hangingPunct="1">
-              <a:lnSpc>
-                <a:spcPct val="100000"/>
-              </a:lnSpc>
-              <a:spcBef>
-                <a:spcPts val="600"/>
-              </a:spcBef>
-              <a:spcAft>
-                <a:spcPts val="600"/>
-              </a:spcAft>
-              <a:buClrTx/>
-              <a:buSzTx/>
-              <a:buFont typeface="Wingdings" pitchFamily="2" charset="2"/>
-              <a:buChar char="ü"/>
-              <a:tabLst/>
-              <a:defRPr/>
-            </a:pPr>
             <a:r>
-              <a:rPr kumimoji="0" lang="en-GB" sz="1400" b="0" i="0" u="none" strike="noStrike" kern="0" cap="none" spc="0" normalizeH="0" baseline="0" noProof="0" dirty="0" smtClean="0">
+              <a:rPr kumimoji="0" lang="en-GB" sz="1800" b="1" i="0" u="none" strike="noStrike" kern="0" cap="none" spc="0" normalizeH="0" baseline="0" noProof="0" dirty="0" smtClean="0">
                 <a:ln>
                   <a:noFill/>
                 </a:ln>
@@ -19289,31 +19088,14 @@
                 <a:uFillTx/>
                 <a:latin typeface="Calibri"/>
                 <a:ea typeface="+mn-ea"/>
-                <a:cs typeface="+mn-cs"/>
+                <a:cs typeface="Arial" charset="0"/>
               </a:rPr>
-              <a:t>Den Service zu verbessern?</a:t>
+              <a:t>den Service zu verbessern?</a:t>
             </a:r>
           </a:p>
           <a:p>
-            <a:pPr marL="285750" marR="0" lvl="0" indent="-285750" defTabSz="1019175" eaLnBrk="1" fontAlgn="base" latinLnBrk="0" hangingPunct="1">
-              <a:lnSpc>
-                <a:spcPct val="100000"/>
-              </a:lnSpc>
-              <a:spcBef>
-                <a:spcPts val="600"/>
-              </a:spcBef>
-              <a:spcAft>
-                <a:spcPts val="600"/>
-              </a:spcAft>
-              <a:buClrTx/>
-              <a:buSzTx/>
-              <a:buFont typeface="Wingdings" pitchFamily="2" charset="2"/>
-              <a:buChar char="ü"/>
-              <a:tabLst/>
-              <a:defRPr/>
-            </a:pPr>
             <a:r>
-              <a:rPr kumimoji="0" lang="en-GB" sz="1400" b="0" i="0" u="none" strike="noStrike" kern="0" cap="none" spc="0" normalizeH="0" baseline="0" noProof="0" dirty="0" smtClean="0">
+              <a:rPr kumimoji="0" lang="en-GB" sz="1800" b="1" i="0" u="none" strike="noStrike" kern="0" cap="none" spc="0" normalizeH="0" baseline="0" noProof="0" dirty="0" smtClean="0">
                 <a:ln>
                   <a:noFill/>
                 </a:ln>
@@ -19325,31 +19107,14 @@
                 <a:uFillTx/>
                 <a:latin typeface="Calibri"/>
                 <a:ea typeface="+mn-ea"/>
-                <a:cs typeface="+mn-cs"/>
+                <a:cs typeface="Arial" charset="0"/>
               </a:rPr>
               <a:t>Kosten zu steuern?</a:t>
             </a:r>
           </a:p>
           <a:p>
-            <a:pPr marL="285750" marR="0" lvl="0" indent="-285750" defTabSz="1019175" eaLnBrk="1" fontAlgn="base" latinLnBrk="0" hangingPunct="1">
-              <a:lnSpc>
-                <a:spcPct val="100000"/>
-              </a:lnSpc>
-              <a:spcBef>
-                <a:spcPts val="600"/>
-              </a:spcBef>
-              <a:spcAft>
-                <a:spcPts val="600"/>
-              </a:spcAft>
-              <a:buClrTx/>
-              <a:buSzTx/>
-              <a:buFont typeface="Wingdings" pitchFamily="2" charset="2"/>
-              <a:buChar char="ü"/>
-              <a:tabLst/>
-              <a:defRPr/>
-            </a:pPr>
             <a:r>
-              <a:rPr kumimoji="0" lang="en-GB" sz="1400" b="0" i="0" u="none" strike="noStrike" kern="0" cap="none" spc="0" normalizeH="0" baseline="0" noProof="0" dirty="0" smtClean="0">
+              <a:rPr kumimoji="0" lang="en-GB" sz="1800" b="1" i="0" u="none" strike="noStrike" kern="0" cap="none" spc="0" normalizeH="0" baseline="0" noProof="0" dirty="0" smtClean="0">
                 <a:ln>
                   <a:noFill/>
                 </a:ln>
@@ -19361,31 +19126,14 @@
                 <a:uFillTx/>
                 <a:latin typeface="Calibri"/>
                 <a:ea typeface="+mn-ea"/>
-                <a:cs typeface="+mn-cs"/>
+                <a:cs typeface="Arial" charset="0"/>
               </a:rPr>
-              <a:t>Den Betrieb zu kontrollieren?</a:t>
+              <a:t>den Betrieb zu kontrollieren?</a:t>
             </a:r>
           </a:p>
           <a:p>
-            <a:pPr marL="285750" marR="0" lvl="0" indent="-285750" defTabSz="1019175" eaLnBrk="1" fontAlgn="base" latinLnBrk="0" hangingPunct="1">
-              <a:lnSpc>
-                <a:spcPct val="100000"/>
-              </a:lnSpc>
-              <a:spcBef>
-                <a:spcPts val="600"/>
-              </a:spcBef>
-              <a:spcAft>
-                <a:spcPts val="600"/>
-              </a:spcAft>
-              <a:buClrTx/>
-              <a:buSzTx/>
-              <a:buFont typeface="Wingdings" pitchFamily="2" charset="2"/>
-              <a:buChar char="ü"/>
-              <a:tabLst/>
-              <a:defRPr/>
-            </a:pPr>
             <a:r>
-              <a:rPr kumimoji="0" lang="en-GB" sz="1400" b="0" i="0" u="none" strike="noStrike" kern="0" cap="none" spc="0" normalizeH="0" baseline="0" noProof="0" dirty="0" smtClean="0">
+              <a:rPr kumimoji="0" lang="en-GB" sz="1800" b="1" i="0" u="none" strike="noStrike" kern="0" cap="none" spc="0" normalizeH="0" baseline="0" noProof="0" dirty="0" smtClean="0">
                 <a:ln>
                   <a:noFill/>
                 </a:ln>
@@ -19397,76 +19145,48 @@
                 <a:uFillTx/>
                 <a:latin typeface="Calibri"/>
                 <a:ea typeface="+mn-ea"/>
-                <a:cs typeface="+mn-cs"/>
+                <a:cs typeface="Arial" charset="0"/>
               </a:rPr>
-              <a:t>Zusammenzuarbeiten?</a:t>
+              <a:t>zusammenzuarbeiten?</a:t>
             </a:r>
           </a:p>
           <a:p>
-            <a:pPr marL="1200150" marR="0" lvl="2" indent="-285750" defTabSz="1019175" eaLnBrk="1" fontAlgn="base" latinLnBrk="0" hangingPunct="1">
-              <a:lnSpc>
-                <a:spcPct val="100000"/>
-              </a:lnSpc>
-              <a:spcBef>
-                <a:spcPts val="600"/>
-              </a:spcBef>
-              <a:spcAft>
-                <a:spcPts val="600"/>
-              </a:spcAft>
-              <a:buClrTx/>
-              <a:buSzTx/>
-              <a:buFont typeface="Wingdings" pitchFamily="2" charset="2"/>
-              <a:buChar char="ü"/>
-              <a:tabLst/>
-              <a:defRPr/>
-            </a:pPr>
-            <a:endParaRPr kumimoji="0" lang="en-GB" sz="1400" b="0" i="0" u="none" strike="noStrike" kern="0" cap="none" spc="0" normalizeH="0" baseline="0" noProof="0" dirty="0" smtClean="0">
-              <a:ln>
-                <a:noFill/>
-              </a:ln>
-              <a:solidFill>
-                <a:schemeClr val="bg1"/>
-              </a:solidFill>
-              <a:effectLst/>
-              <a:uLnTx/>
-              <a:uFillTx/>
-              <a:latin typeface="Calibri"/>
-              <a:ea typeface="+mn-ea"/>
-              <a:cs typeface="+mn-cs"/>
-            </a:endParaRPr>
-          </a:p>
-          <a:p>
-            <a:pPr marL="0" marR="0" lvl="0" indent="0" defTabSz="1019175" eaLnBrk="1" fontAlgn="base" latinLnBrk="0" hangingPunct="1">
-              <a:lnSpc>
-                <a:spcPct val="100000"/>
-              </a:lnSpc>
-              <a:spcBef>
-                <a:spcPts val="600"/>
-              </a:spcBef>
-              <a:spcAft>
-                <a:spcPts val="600"/>
-              </a:spcAft>
-              <a:buClrTx/>
-              <a:buSzTx/>
-              <a:buFontTx/>
-              <a:buNone/>
-              <a:tabLst/>
-              <a:defRPr/>
-            </a:pPr>
-            <a:endParaRPr kumimoji="0" lang="en-GB" sz="1800" b="0" i="0" u="none" strike="noStrike" kern="0" cap="none" spc="0" normalizeH="0" baseline="0" noProof="0" dirty="0" smtClean="0">
-              <a:ln>
-                <a:noFill/>
-              </a:ln>
-              <a:solidFill>
-                <a:schemeClr val="bg1"/>
-              </a:solidFill>
-              <a:effectLst/>
-              <a:uLnTx/>
-              <a:uFillTx/>
-              <a:latin typeface="Calibri"/>
-              <a:ea typeface="+mn-ea"/>
-              <a:cs typeface="Arial" charset="0"/>
-            </a:endParaRPr>
+            <a:r>
+              <a:rPr kumimoji="0" lang="en-GB" sz="1800" b="1" i="0" u="none" strike="noStrike" kern="0" cap="none" spc="0" normalizeH="0" baseline="0" noProof="0" dirty="0" smtClean="0">
+                <a:ln>
+                  <a:noFill/>
+                </a:ln>
+                <a:solidFill>
+                  <a:schemeClr val="bg1"/>
+                </a:solidFill>
+                <a:effectLst/>
+                <a:uLnTx/>
+                <a:uFillTx/>
+                <a:latin typeface="Calibri"/>
+                <a:ea typeface="+mn-ea"/>
+                <a:cs typeface="Arial" charset="0"/>
+              </a:rPr>
+              <a:t/>
+            </a:r>
+          </a:p>
+          <a:p>
+            <a:r>
+              <a:rPr kumimoji="0" lang="en-GB" sz="1800" b="1" i="0" u="none" strike="noStrike" kern="0" cap="none" spc="0" normalizeH="0" baseline="0" noProof="0" dirty="0" smtClean="0">
+                <a:ln>
+                  <a:noFill/>
+                </a:ln>
+                <a:solidFill>
+                  <a:schemeClr val="bg1"/>
+                </a:solidFill>
+                <a:effectLst/>
+                <a:uLnTx/>
+                <a:uFillTx/>
+                <a:latin typeface="Calibri"/>
+                <a:ea typeface="+mn-ea"/>
+                <a:cs typeface="Arial" charset="0"/>
+              </a:rPr>
+              <a:t/>
+            </a:r>
           </a:p>
         </p:txBody>
       </p:sp>
@@ -19551,18 +19271,12 @@
           </a:bodyPr>
           <a:lstStyle/>
           <a:p>
-            <a:pPr algn="ctr">
-              <a:defRPr/>
-            </a:pPr>
             <a:r>
               <a:rPr lang="en-US" b="1" kern="0" dirty="0" smtClean="0">
                 <a:latin typeface="Calibri"/>
               </a:rPr>
-              <a:t>Internet of Things</a:t>
+              <a:t>Internet der Dinge</a:t>
             </a:r>
-            <a:endParaRPr lang="en-US" b="1" kern="0" dirty="0">
-              <a:latin typeface="Calibri"/>
-            </a:endParaRPr>
           </a:p>
         </p:txBody>
       </p:sp>
@@ -19629,18 +19343,12 @@
           </a:bodyPr>
           <a:lstStyle/>
           <a:p>
-            <a:pPr algn="ctr">
-              <a:defRPr/>
-            </a:pPr>
             <a:r>
               <a:rPr lang="en-US" b="1" kern="0" dirty="0" smtClean="0">
                 <a:latin typeface="Calibri"/>
               </a:rPr>
-              <a:t>Internettransaktionen</a:t>
+              <a:t>Internet-Transaktionen</a:t>
             </a:r>
-            <a:endParaRPr lang="en-US" b="1" kern="0" dirty="0">
-              <a:latin typeface="Calibri"/>
-            </a:endParaRPr>
           </a:p>
         </p:txBody>
       </p:sp>
@@ -19730,9 +19438,8 @@
           <a:p>
             <a:r>
               <a:rPr lang="en-GB" dirty="0" smtClean="0"/>
-              <a:t>Wichtigste Trends</a:t>
+              <a:t>Zentrale Trends</a:t>
             </a:r>
-            <a:endParaRPr lang="en-GB" dirty="0"/>
           </a:p>
         </p:txBody>
       </p:sp>
@@ -19774,12 +19481,10 @@
           <a:bodyPr lIns="0" rIns="0" rtlCol="0" anchor="ctr"/>
           <a:lstStyle/>
           <a:p>
-            <a:pPr algn="ctr"/>
             <a:r>
               <a:rPr lang="en-GB" sz="1600" dirty="0" smtClean="0"/>
               <a:t>Personalisierung</a:t>
             </a:r>
-            <a:endParaRPr lang="en-GB" sz="1600" dirty="0"/>
           </a:p>
         </p:txBody>
       </p:sp>
@@ -19821,12 +19526,10 @@
           <a:bodyPr lIns="0" rIns="0" rtlCol="0" anchor="ctr"/>
           <a:lstStyle/>
           <a:p>
-            <a:pPr algn="ctr"/>
             <a:r>
               <a:rPr lang="en-GB" sz="1600" dirty="0" smtClean="0"/>
               <a:t>Automatisierung</a:t>
             </a:r>
-            <a:endParaRPr lang="en-GB" sz="1600" dirty="0"/>
           </a:p>
         </p:txBody>
       </p:sp>
@@ -19868,12 +19571,10 @@
           <a:bodyPr lIns="0" rIns="0" rtlCol="0" anchor="ctr"/>
           <a:lstStyle/>
           <a:p>
-            <a:pPr algn="ctr"/>
             <a:r>
               <a:rPr lang="en-GB" sz="1600" dirty="0" smtClean="0"/>
               <a:t>Geschwindigkeit und Agilität</a:t>
             </a:r>
-            <a:endParaRPr lang="en-GB" sz="1600" dirty="0"/>
           </a:p>
         </p:txBody>
       </p:sp>
@@ -19915,12 +19616,10 @@
           <a:bodyPr lIns="0" rIns="0" rtlCol="0" anchor="ctr"/>
           <a:lstStyle/>
           <a:p>
-            <a:pPr algn="ctr"/>
             <a:r>
               <a:rPr lang="en-GB" sz="1600" dirty="0" smtClean="0"/>
               <a:t>Skalierbarkeit</a:t>
             </a:r>
-            <a:endParaRPr lang="en-GB" sz="1600" dirty="0"/>
           </a:p>
         </p:txBody>
       </p:sp>
@@ -19962,12 +19661,10 @@
           <a:bodyPr lIns="0" rIns="0" rtlCol="0" anchor="ctr"/>
           <a:lstStyle/>
           <a:p>
-            <a:pPr algn="ctr"/>
             <a:r>
               <a:rPr lang="en-GB" sz="1600" dirty="0" smtClean="0"/>
               <a:t>On-Premise vs. Cloud</a:t>
             </a:r>
-            <a:endParaRPr lang="en-GB" sz="1600" dirty="0"/>
           </a:p>
         </p:txBody>
       </p:sp>
@@ -20009,12 +19706,10 @@
           <a:bodyPr lIns="0" rIns="0" rtlCol="0" anchor="ctr"/>
           <a:lstStyle/>
           <a:p>
-            <a:pPr algn="ctr"/>
             <a:r>
               <a:rPr lang="en-GB" sz="1600" dirty="0" smtClean="0"/>
-              <a:t>Best-of-Breed vs. Einzelplattformlösung</a:t>
+              <a:t>Best-of-Breed vs. Einzelplattform-Lösung</a:t>
             </a:r>
-            <a:endParaRPr lang="en-GB" sz="1600" dirty="0"/>
           </a:p>
         </p:txBody>
       </p:sp>
@@ -20103,12 +19798,10 @@
           <a:bodyPr lIns="0" rIns="0" rtlCol="0" anchor="ctr"/>
           <a:lstStyle/>
           <a:p>
-            <a:pPr algn="ctr"/>
             <a:r>
               <a:rPr lang="en-GB" sz="1600" dirty="0" smtClean="0"/>
               <a:t>Disruptoren</a:t>
             </a:r>
-            <a:endParaRPr lang="en-GB" sz="1600" dirty="0"/>
           </a:p>
         </p:txBody>
       </p:sp>
@@ -20150,12 +19843,10 @@
           <a:bodyPr lIns="0" rIns="0" rtlCol="0" anchor="ctr"/>
           <a:lstStyle/>
           <a:p>
-            <a:pPr algn="ctr"/>
             <a:r>
               <a:rPr lang="en-GB" sz="1600" dirty="0" smtClean="0"/>
-              <a:t>Zugänglichkeit  „Benutzerfreundlichkeit“</a:t>
+              <a:t>Zugänglichkeit – „einfache Bedienung“</a:t>
             </a:r>
-            <a:endParaRPr lang="en-GB" sz="1600" dirty="0"/>
           </a:p>
         </p:txBody>
       </p:sp>
@@ -20215,17 +19906,8 @@
           <a:p>
             <a:r>
               <a:rPr lang="en-US" sz="3200" dirty="0" smtClean="0"/>
-              <a:t>Wie können digitale Werkzeuge meiner </a:t>
+              <a:t>Wie können digitale Werkzeuge meiner Organisation helfen, unsere Ziele zu erreichen?</a:t>
             </a:r>
-            <a:r>
-              <a:rPr lang="en-US" sz="3200" dirty="0" err="1" smtClean="0"/>
-              <a:t>Organisation</a:t>
-            </a:r>
-            <a:r>
-              <a:rPr lang="en-US" sz="3200" dirty="0" smtClean="0"/>
-              <a:t> helfen, unsere Ziele zu erreichen?</a:t>
-            </a:r>
-            <a:endParaRPr lang="en-US" sz="3200" dirty="0"/>
           </a:p>
         </p:txBody>
       </p:sp>
@@ -20285,7 +19967,6 @@
               <a:rPr lang="en-GB" dirty="0" smtClean="0"/>
               <a:t>IT-Strategie</a:t>
             </a:r>
-            <a:endParaRPr lang="en-GB" dirty="0"/>
           </a:p>
         </p:txBody>
       </p:sp>
@@ -20345,25 +20026,8 @@
           <a:p>
             <a:r>
               <a:rPr lang="en-US" i="1" dirty="0" smtClean="0"/>
-              <a:t>…[</a:t>
+              <a:t>… [digitale] Technologien wie soziale Medien, Mobilität und Datenanalyse sind keine Ziele, die es zu erreichen gilt … [sondern] sie sind Werkzeuge, um näher an die Kunden zu rücken, Mitarbeitende zu befähigen und interne Geschäftsprozesse zu transformieren.</a:t>
             </a:r>
-            <a:r>
-              <a:rPr lang="en-US" i="1" dirty="0"/>
-              <a:t>digitale] Technologien wie soziale Medien, Mobilität und Datenanalytik sind keine Ziele, die es </a:t>
-            </a:r>
-            <a:r>
-              <a:rPr lang="en-US" i="1" dirty="0" smtClean="0"/>
-              <a:t>zu erreichen gilt…[</a:t>
-            </a:r>
-            <a:r>
-              <a:rPr lang="en-US" i="1" dirty="0"/>
-              <a:t>sondern] sind Werkzeuge, um Kunden näher zu kommen, Mitarbeitende zu befähigen und interne Geschäfts</a:t>
-            </a:r>
-            <a:r>
-              <a:rPr lang="en-US" i="1" dirty="0" smtClean="0"/>
-              <a:t>prozesse zu transformieren </a:t>
-            </a:r>
-            <a:endParaRPr lang="en-US" i="1" dirty="0"/>
           </a:p>
         </p:txBody>
       </p:sp>
@@ -20524,83 +20188,14 @@
             </a:lvl9pPr>
           </a:lstStyle>
           <a:p>
-            <a:pPr marL="0" indent="0" algn="ctr">
-              <a:buNone/>
-            </a:pPr>
             <a:r>
               <a:rPr lang="en-US" sz="1400" b="1" dirty="0" err="1" smtClean="0">
                 <a:solidFill>
                   <a:schemeClr val="bg1"/>
                 </a:solidFill>
               </a:rPr>
-              <a:t>Westman</a:t>
+              <a:t>Westman, Bonnie und McAfee, „Leading Digital: Turning Technology into Business Transformation“ (HBR, 2014)</a:t>
             </a:r>
-            <a:r>
-              <a:rPr lang="en-US" sz="1400" b="1" dirty="0">
-                <a:solidFill>
-                  <a:schemeClr val="bg1"/>
-                </a:solidFill>
-              </a:rPr>
-              <a:t>, Bonnie und </a:t>
-            </a:r>
-            <a:r>
-              <a:rPr lang="en-US" sz="1400" b="1" dirty="0" smtClean="0">
-                <a:solidFill>
-                  <a:schemeClr val="bg1"/>
-                </a:solidFill>
-              </a:rPr>
-              <a:t>McAfee</a:t>
-            </a:r>
-            <a:r>
-              <a:rPr lang="en-US" sz="1400" dirty="0" smtClean="0">
-                <a:solidFill>
-                  <a:schemeClr val="bg1"/>
-                </a:solidFill>
-              </a:rPr>
-              <a:t>, </a:t>
-            </a:r>
-            <a:r>
-              <a:rPr lang="en-US" sz="1400" dirty="0" smtClean="0">
-                <a:solidFill>
-                  <a:schemeClr val="bg1"/>
-                </a:solidFill>
-                <a:latin typeface="+mj-lt"/>
-              </a:rPr>
-              <a:t>„</a:t>
-            </a:r>
-            <a:r>
-              <a:rPr lang="en-US" sz="1400" i="1" dirty="0" smtClean="0">
-                <a:solidFill>
-                  <a:schemeClr val="bg1"/>
-                </a:solidFill>
-                <a:latin typeface="+mj-lt"/>
-              </a:rPr>
-              <a:t>Leading Digital: Turning Technology into Business Transformation</a:t>
-            </a:r>
-            <a:r>
-              <a:rPr lang="en-US" sz="1400" dirty="0" smtClean="0">
-                <a:solidFill>
-                  <a:schemeClr val="bg1"/>
-                </a:solidFill>
-                <a:latin typeface="+mj-lt"/>
-              </a:rPr>
-              <a:t>“ (</a:t>
-            </a:r>
-            <a:r>
-              <a:rPr lang="en-US" sz="1400" dirty="0">
-                <a:solidFill>
-                  <a:schemeClr val="bg1"/>
-                </a:solidFill>
-                <a:latin typeface="+mj-lt"/>
-              </a:rPr>
-              <a:t>HBR, 2014) </a:t>
-            </a:r>
-            <a:endParaRPr lang="en-GB" sz="1400" dirty="0">
-              <a:solidFill>
-                <a:schemeClr val="bg1"/>
-              </a:solidFill>
-              <a:latin typeface="+mj-lt"/>
-            </a:endParaRPr>
           </a:p>
         </p:txBody>
       </p:sp>
@@ -20660,7 +20255,6 @@
               <a:rPr lang="en-GB" dirty="0" smtClean="0"/>
               <a:t>Traditionelle Säulen der IT-Strategie</a:t>
             </a:r>
-            <a:endParaRPr lang="en-GB" dirty="0"/>
           </a:p>
         </p:txBody>
       </p:sp>
@@ -20798,23 +20392,6 @@
             <a:bodyPr wrap="none" lIns="0" tIns="0" rIns="0" bIns="0" anchor="ctr"/>
             <a:lstStyle/>
             <a:p>
-              <a:pPr marL="0" marR="0" lvl="0" indent="0" algn="ctr" defTabSz="914400" eaLnBrk="1" fontAlgn="auto" latinLnBrk="0" hangingPunct="1">
-                <a:lnSpc>
-                  <a:spcPct val="80000"/>
-                </a:lnSpc>
-                <a:spcBef>
-                  <a:spcPct val="20000"/>
-                </a:spcBef>
-                <a:spcAft>
-                  <a:spcPts val="0"/>
-                </a:spcAft>
-                <a:buClrTx/>
-                <a:buSzTx/>
-                <a:buFont typeface="Wingdings 2" pitchFamily="18" charset="2"/>
-                <a:buNone/>
-                <a:tabLst/>
-                <a:defRPr/>
-              </a:pPr>
               <a:r>
                 <a:rPr kumimoji="0" lang="en-US" sz="1200" b="1" i="0" u="none" strike="noStrike" kern="0" cap="none" spc="0" normalizeH="0" baseline="0" noProof="0" dirty="0">
                   <a:ln>
@@ -20829,53 +20406,10 @@
                   <a:uLnTx/>
                   <a:uFillTx/>
                 </a:rPr>
-                <a:t>IT-Personal </a:t>
+                <a:t>IT-Personal</a:t>
               </a:r>
             </a:p>
             <a:p>
-              <a:pPr marL="0" marR="0" lvl="0" indent="0" algn="ctr" defTabSz="914400" eaLnBrk="1" fontAlgn="auto" latinLnBrk="0" hangingPunct="1">
-                <a:lnSpc>
-                  <a:spcPct val="80000"/>
-                </a:lnSpc>
-                <a:spcBef>
-                  <a:spcPct val="20000"/>
-                </a:spcBef>
-                <a:spcAft>
-                  <a:spcPts val="0"/>
-                </a:spcAft>
-                <a:buClrTx/>
-                <a:buSzTx/>
-                <a:buFont typeface="Wingdings 2" pitchFamily="18" charset="2"/>
-                <a:buNone/>
-                <a:tabLst/>
-                <a:defRPr/>
-              </a:pPr>
-              <a:r>
-                <a:rPr lang="en-US" sz="1200" b="1" kern="0" dirty="0" smtClean="0">
-                  <a:solidFill>
-                    <a:srgbClr val="FFFFFF">
-                      <a:lumMod val="95000"/>
-                    </a:srgbClr>
-                  </a:solidFill>
-                </a:rPr>
-                <a:t>und</a:t>
-              </a:r>
-              <a:r>
-                <a:rPr kumimoji="0" lang="en-US" sz="1200" b="1" i="0" u="none" strike="noStrike" kern="0" cap="none" spc="0" normalizeH="0" baseline="0" noProof="0" dirty="0" smtClean="0">
-                  <a:ln>
-                    <a:noFill/>
-                  </a:ln>
-                  <a:solidFill>
-                    <a:srgbClr val="FFFFFF">
-                      <a:lumMod val="95000"/>
-                    </a:srgbClr>
-                  </a:solidFill>
-                  <a:effectLst/>
-                  <a:uLnTx/>
-                  <a:uFillTx/>
-                </a:rPr>
-                <a:t> </a:t>
-              </a:r>
               <a:r>
                 <a:rPr kumimoji="0" lang="en-US" sz="1200" b="1" i="0" u="none" strike="noStrike" kern="0" cap="none" spc="0" normalizeH="0" baseline="0" noProof="0" dirty="0">
                   <a:ln>
@@ -20890,7 +20424,7 @@
                   <a:uLnTx/>
                   <a:uFillTx/>
                 </a:rPr>
-                <a:t>Support</a:t>
+                <a:t>und -Support</a:t>
               </a:r>
             </a:p>
           </p:txBody>
@@ -20936,23 +20470,6 @@
             <a:bodyPr wrap="none" lIns="0" tIns="0" rIns="0" bIns="0" anchor="ctr"/>
             <a:lstStyle/>
             <a:p>
-              <a:pPr marL="0" marR="0" lvl="0" indent="0" algn="ctr" defTabSz="914400" eaLnBrk="1" fontAlgn="auto" latinLnBrk="0" hangingPunct="1">
-                <a:lnSpc>
-                  <a:spcPct val="100000"/>
-                </a:lnSpc>
-                <a:spcBef>
-                  <a:spcPts val="0"/>
-                </a:spcBef>
-                <a:spcAft>
-                  <a:spcPts val="0"/>
-                </a:spcAft>
-                <a:buClrTx/>
-                <a:buSzTx/>
-                <a:buFontTx/>
-                <a:buNone/>
-                <a:tabLst/>
-                <a:defRPr/>
-              </a:pPr>
               <a:r>
                 <a:rPr kumimoji="0" lang="en-US" sz="1200" b="1" i="0" u="none" strike="noStrike" kern="0" cap="none" spc="0" normalizeH="0" baseline="0" noProof="0" dirty="0">
                   <a:ln>
@@ -20972,67 +20489,25 @@
               </a:r>
             </a:p>
             <a:p>
-              <a:pPr marL="0" marR="0" lvl="0" indent="0" algn="ctr" defTabSz="914400" eaLnBrk="1" fontAlgn="auto" latinLnBrk="0" hangingPunct="1">
-                <a:lnSpc>
-                  <a:spcPct val="100000"/>
-                </a:lnSpc>
-                <a:spcBef>
-                  <a:spcPts val="0"/>
-                </a:spcBef>
-                <a:spcAft>
-                  <a:spcPts val="0"/>
-                </a:spcAft>
-                <a:buClrTx/>
-                <a:buSzTx/>
-                <a:buFontTx/>
-                <a:buNone/>
-                <a:tabLst/>
-                <a:defRPr/>
-              </a:pPr>
               <a:r>
-                <a:rPr lang="en-US" sz="1200" b="1" kern="0" dirty="0" smtClean="0">
+                <a:rPr kumimoji="0" lang="en-US" sz="1200" b="1" i="0" u="none" strike="noStrike" kern="0" cap="none" spc="0" normalizeH="0" baseline="0" noProof="0" dirty="0">
+                  <a:ln>
+                    <a:noFill/>
+                  </a:ln>
                   <a:solidFill>
                     <a:srgbClr val="FFFFFF">
                       <a:lumMod val="95000"/>
                     </a:srgbClr>
                   </a:solidFill>
+                  <a:effectLst/>
+                  <a:uLnTx/>
+                  <a:uFillTx/>
                   <a:cs typeface="Arial" pitchFamily="34" charset="0"/>
                 </a:rPr>
                 <a:t>und</a:t>
               </a:r>
-              <a:endParaRPr kumimoji="0" lang="en-US" sz="1200" b="1" i="0" u="none" strike="noStrike" kern="0" cap="none" spc="0" normalizeH="0" baseline="0" noProof="0" dirty="0">
-                <a:ln>
-                  <a:noFill/>
-                </a:ln>
-                <a:solidFill>
-                  <a:srgbClr val="FFFFFF">
-                    <a:lumMod val="95000"/>
-                  </a:srgbClr>
-                </a:solidFill>
-                <a:effectLst/>
-                <a:uLnTx/>
-                <a:uFillTx/>
-                <a:cs typeface="Arial" pitchFamily="34" charset="0"/>
-              </a:endParaRPr>
             </a:p>
             <a:p>
-              <a:pPr marL="0" marR="0" lvl="0" indent="0" algn="ctr" defTabSz="914400" eaLnBrk="1" fontAlgn="auto" latinLnBrk="0" hangingPunct="1">
-                <a:lnSpc>
-                  <a:spcPct val="100000"/>
-                </a:lnSpc>
-                <a:spcBef>
-                  <a:spcPts val="0"/>
-                </a:spcBef>
-                <a:spcAft>
-                  <a:spcPts val="0"/>
-                </a:spcAft>
-                <a:buClrTx/>
-                <a:buSzTx/>
-                <a:buFontTx/>
-                <a:buNone/>
-                <a:tabLst/>
-                <a:defRPr/>
-              </a:pPr>
               <a:r>
                 <a:rPr kumimoji="0" lang="en-US" sz="1200" b="1" i="0" u="none" strike="noStrike" kern="0" cap="none" spc="0" normalizeH="0" baseline="0" noProof="0" dirty="0">
                   <a:ln>
@@ -21302,23 +20777,6 @@
           </a:bodyPr>
           <a:lstStyle/>
           <a:p>
-            <a:pPr marL="0" marR="0" lvl="0" indent="0" algn="ctr" defTabSz="914400" eaLnBrk="1" fontAlgn="auto" latinLnBrk="0" hangingPunct="1">
-              <a:lnSpc>
-                <a:spcPct val="100000"/>
-              </a:lnSpc>
-              <a:spcBef>
-                <a:spcPts val="0"/>
-              </a:spcBef>
-              <a:spcAft>
-                <a:spcPts val="0"/>
-              </a:spcAft>
-              <a:buClrTx/>
-              <a:buSzTx/>
-              <a:buFontTx/>
-              <a:buNone/>
-              <a:tabLst/>
-              <a:defRPr/>
-            </a:pPr>
             <a:r>
               <a:rPr kumimoji="0" lang="en-US" sz="1200" b="1" i="0" u="none" strike="noStrike" kern="0" cap="none" spc="0" normalizeH="0" baseline="0" noProof="0" dirty="0">
                 <a:ln>
@@ -21337,46 +20795,22 @@
             </a:r>
           </a:p>
           <a:p>
-            <a:pPr marL="0" marR="0" lvl="0" indent="0" algn="ctr" defTabSz="914400" eaLnBrk="1" fontAlgn="auto" latinLnBrk="0" hangingPunct="1">
-              <a:lnSpc>
-                <a:spcPct val="100000"/>
-              </a:lnSpc>
-              <a:spcBef>
-                <a:spcPts val="0"/>
-              </a:spcBef>
-              <a:spcAft>
-                <a:spcPts val="0"/>
-              </a:spcAft>
-              <a:buClrTx/>
-              <a:buSzTx/>
-              <a:buFontTx/>
-              <a:buNone/>
-              <a:tabLst/>
-              <a:defRPr/>
-            </a:pPr>
             <a:r>
-              <a:rPr lang="en-US" sz="1200" b="1" kern="0" dirty="0">
+              <a:rPr kumimoji="0" lang="en-US" sz="1200" b="1" i="0" u="none" strike="noStrike" kern="0" cap="none" spc="0" normalizeH="0" baseline="0" noProof="0" dirty="0">
+                <a:ln>
+                  <a:noFill/>
+                </a:ln>
                 <a:solidFill>
                   <a:srgbClr val="FFFFFF">
                     <a:lumMod val="95000"/>
                   </a:srgbClr>
                 </a:solidFill>
+                <a:effectLst/>
+                <a:uLnTx/>
+                <a:uFillTx/>
               </a:rPr>
               <a:t>Governance</a:t>
             </a:r>
-            <a:endParaRPr kumimoji="0" lang="en-US" sz="1200" b="0" i="0" u="none" strike="noStrike" kern="0" cap="none" spc="0" normalizeH="0" baseline="0" noProof="0" dirty="0">
-              <a:ln>
-                <a:noFill/>
-              </a:ln>
-              <a:solidFill>
-                <a:srgbClr val="FFFFFF">
-                  <a:lumMod val="95000"/>
-                </a:srgbClr>
-              </a:solidFill>
-              <a:effectLst/>
-              <a:uLnTx/>
-              <a:uFillTx/>
-            </a:endParaRPr>
           </a:p>
         </p:txBody>
       </p:sp>
@@ -21410,23 +20844,6 @@
           </a:bodyPr>
           <a:lstStyle/>
           <a:p>
-            <a:pPr marL="0" marR="0" lvl="0" indent="0" algn="r" defTabSz="914400" eaLnBrk="1" fontAlgn="auto" latinLnBrk="0" hangingPunct="1">
-              <a:lnSpc>
-                <a:spcPct val="100000"/>
-              </a:lnSpc>
-              <a:spcBef>
-                <a:spcPts val="0"/>
-              </a:spcBef>
-              <a:spcAft>
-                <a:spcPts val="0"/>
-              </a:spcAft>
-              <a:buClrTx/>
-              <a:buSzTx/>
-              <a:buFontTx/>
-              <a:buNone/>
-              <a:tabLst/>
-              <a:defRPr/>
-            </a:pPr>
             <a:r>
               <a:rPr kumimoji="0" lang="en-US" sz="1050" b="0" i="0" u="none" strike="noStrike" kern="0" cap="none" spc="0" normalizeH="0" baseline="0" noProof="0" dirty="0">
                 <a:ln>
@@ -21436,28 +20853,7 @@
                 <a:uLnTx/>
                 <a:uFillTx/>
               </a:rPr>
-              <a:t>IT-Projekte müssen mit der Unternehmensstrategie abgestimmt sein, die IT-Leistung sollte regelmäßig überwacht werden, und es sollte eine effektive Kommunikation zwischen IT und</a:t>
-            </a:r>
-            <a:br>
-              <a:rPr kumimoji="0" lang="en-US" sz="1050" b="0" i="0" u="none" strike="noStrike" kern="0" cap="none" spc="0" normalizeH="0" baseline="0" noProof="0" dirty="0">
-                <a:ln>
-                  <a:noFill/>
-                </a:ln>
-                <a:effectLst/>
-                <a:uLnTx/>
-                <a:uFillTx/>
-              </a:rPr>
-            </a:br>
-            <a:r>
-              <a:rPr kumimoji="0" lang="en-US" sz="1050" b="0" i="0" u="none" strike="noStrike" kern="0" cap="none" spc="0" normalizeH="0" baseline="0" noProof="0" dirty="0">
-                <a:ln>
-                  <a:noFill/>
-                </a:ln>
-                <a:effectLst/>
-                <a:uLnTx/>
-                <a:uFillTx/>
-              </a:rPr>
-              <a:t>Geschäftsanwendern bestehen.</a:t>
+              <a:t>IT-Projekte müssen auf die Unternehmensstrategie abgestimmt sein, die IT-Leistung sollte regelmäßig überwacht werden, und es sollte eine wirksame Kommunikation zwischen IT und Fachanwendern bestehen.</a:t>
             </a:r>
           </a:p>
         </p:txBody>
@@ -21492,23 +20888,6 @@
           </a:bodyPr>
           <a:lstStyle/>
           <a:p>
-            <a:pPr marL="0" marR="0" lvl="0" indent="0" algn="r" defTabSz="914400" eaLnBrk="1" fontAlgn="auto" latinLnBrk="0" hangingPunct="1">
-              <a:lnSpc>
-                <a:spcPct val="100000"/>
-              </a:lnSpc>
-              <a:spcBef>
-                <a:spcPts val="0"/>
-              </a:spcBef>
-              <a:spcAft>
-                <a:spcPts val="0"/>
-              </a:spcAft>
-              <a:buClrTx/>
-              <a:buSzTx/>
-              <a:buFontTx/>
-              <a:buNone/>
-              <a:tabLst/>
-              <a:defRPr/>
-            </a:pPr>
             <a:r>
               <a:rPr kumimoji="0" lang="en-US" sz="1050" b="0" i="0" u="none" strike="noStrike" kern="0" cap="none" spc="0" normalizeH="0" baseline="0" noProof="0" dirty="0">
                 <a:ln>
@@ -21518,70 +20897,7 @@
                 <a:uLnTx/>
                 <a:uFillTx/>
               </a:rPr>
-              <a:t>IT-Personalbesetzung und IT-Support-Vereinbarungen müssen dem jeweiligen Bedarf angemessen sein, mit den erforderlichen Qualifikationen</a:t>
-            </a:r>
-            <a:br>
-              <a:rPr kumimoji="0" lang="en-US" sz="1050" b="0" i="0" u="none" strike="noStrike" kern="0" cap="none" spc="0" normalizeH="0" baseline="0" noProof="0" dirty="0">
-                <a:ln>
-                  <a:noFill/>
-                </a:ln>
-                <a:effectLst/>
-                <a:uLnTx/>
-                <a:uFillTx/>
-              </a:rPr>
-            </a:br>
-            <a:r>
-              <a:rPr kumimoji="0" lang="en-US" sz="1050" b="0" i="0" u="none" strike="noStrike" kern="0" cap="none" spc="0" normalizeH="0" baseline="0" noProof="0" dirty="0">
-                <a:ln>
-                  <a:noFill/>
-                </a:ln>
-                <a:effectLst/>
-                <a:uLnTx/>
-                <a:uFillTx/>
-              </a:rPr>
-              <a:t>sowie Karrierepfaden</a:t>
-            </a:r>
-            <a:br>
-              <a:rPr kumimoji="0" lang="en-US" sz="1050" b="0" i="0" u="none" strike="noStrike" kern="0" cap="none" spc="0" normalizeH="0" baseline="0" noProof="0" dirty="0">
-                <a:ln>
-                  <a:noFill/>
-                </a:ln>
-                <a:effectLst/>
-                <a:uLnTx/>
-                <a:uFillTx/>
-              </a:rPr>
-            </a:br>
-            <a:r>
-              <a:rPr kumimoji="0" lang="en-US" sz="1050" b="0" i="0" u="none" strike="noStrike" kern="0" cap="none" spc="0" normalizeH="0" baseline="0" noProof="0" dirty="0">
-                <a:ln>
-                  <a:noFill/>
-                </a:ln>
-                <a:effectLst/>
-                <a:uLnTx/>
-                <a:uFillTx/>
-              </a:rPr>
-              <a:t>und Bindungsplänen</a:t>
-            </a:r>
-            <a:br>
-              <a:rPr kumimoji="0" lang="en-US" sz="1050" b="0" i="0" u="none" strike="noStrike" kern="0" cap="none" spc="0" normalizeH="0" baseline="0" noProof="0" dirty="0">
-                <a:ln>
-                  <a:noFill/>
-                </a:ln>
-                <a:effectLst/>
-                <a:uLnTx/>
-                <a:uFillTx/>
-              </a:rPr>
-            </a:br>
-            <a:r>
-              <a:rPr kumimoji="0" lang="en-US" sz="1050" b="0" i="0" u="none" strike="noStrike" kern="0" cap="none" spc="0" normalizeH="0" baseline="0" noProof="0" dirty="0">
-                <a:ln>
-                  <a:noFill/>
-                </a:ln>
-                <a:effectLst/>
-                <a:uLnTx/>
-                <a:uFillTx/>
-              </a:rPr>
-              <a:t>für die Mitarbeitenden. </a:t>
+              <a:t>IT-Personal und IT-Support müssen dem Bedarf angemessen sein, mit den erforderlichen Kompetenzen sowie Karrierepfaden und Bindungskonzepten für die Mitarbeitenden.</a:t>
             </a:r>
           </a:p>
         </p:txBody>
@@ -21616,23 +20932,6 @@
           </a:bodyPr>
           <a:lstStyle/>
           <a:p>
-            <a:pPr marL="0" marR="0" lvl="0" indent="0" defTabSz="914400" eaLnBrk="1" fontAlgn="auto" latinLnBrk="0" hangingPunct="1">
-              <a:lnSpc>
-                <a:spcPct val="100000"/>
-              </a:lnSpc>
-              <a:spcBef>
-                <a:spcPts val="0"/>
-              </a:spcBef>
-              <a:spcAft>
-                <a:spcPts val="0"/>
-              </a:spcAft>
-              <a:buClrTx/>
-              <a:buSzTx/>
-              <a:buFontTx/>
-              <a:buNone/>
-              <a:tabLst/>
-              <a:defRPr/>
-            </a:pPr>
             <a:r>
               <a:rPr kumimoji="0" lang="en-US" sz="1050" b="0" i="0" u="none" strike="noStrike" kern="0" cap="none" spc="0" normalizeH="0" baseline="0" noProof="0" dirty="0">
                 <a:ln>
@@ -21642,66 +20941,34 @@
                 <a:uLnTx/>
                 <a:uFillTx/>
               </a:rPr>
-              <a:t>IT-Systeme müssen den Geschäftsanforderungen entsprechen, Daten müssen gut verwaltet und zugänglich sein, und die Infrastruktur muss effektiv überwacht und gewartet werden.</a:t>
+              <a:t>IT-Systeme müssen für die Geschäftsanforderungen geeignet sein, Daten müssen gut verwaltet und zugänglich sein, und die Infrastruktur muss wirksam überwacht und gewartet werden.</a:t>
             </a:r>
           </a:p>
           <a:p>
-            <a:pPr marL="0" marR="0" lvl="0" indent="0" defTabSz="914400" eaLnBrk="1" fontAlgn="auto" latinLnBrk="0" hangingPunct="1">
-              <a:lnSpc>
-                <a:spcPct val="100000"/>
-              </a:lnSpc>
-              <a:spcBef>
-                <a:spcPts val="0"/>
-              </a:spcBef>
-              <a:spcAft>
-                <a:spcPts val="0"/>
-              </a:spcAft>
-              <a:buClrTx/>
-              <a:buSzTx/>
-              <a:buFontTx/>
-              <a:buNone/>
-              <a:tabLst/>
-              <a:defRPr/>
-            </a:pPr>
-            <a:endParaRPr lang="en-US" sz="1050" kern="0" dirty="0">
-              <a:solidFill>
-                <a:srgbClr val="888B8D">
-                  <a:lumMod val="50000"/>
-                </a:srgbClr>
-              </a:solidFill>
-            </a:endParaRPr>
-          </a:p>
-          <a:p>
-            <a:pPr marL="0" marR="0" lvl="0" indent="0" defTabSz="914400" eaLnBrk="1" fontAlgn="auto" latinLnBrk="0" hangingPunct="1">
-              <a:lnSpc>
-                <a:spcPct val="100000"/>
-              </a:lnSpc>
-              <a:spcBef>
-                <a:spcPts val="0"/>
-              </a:spcBef>
-              <a:spcAft>
-                <a:spcPts val="0"/>
-              </a:spcAft>
-              <a:buClrTx/>
-              <a:buSzTx/>
-              <a:buFontTx/>
-              <a:buNone/>
-              <a:tabLst/>
-              <a:defRPr/>
-            </a:pPr>
-            <a:endParaRPr kumimoji="0" lang="en-US" sz="1050" b="0" i="0" u="none" strike="noStrike" kern="0" cap="none" spc="0" normalizeH="0" baseline="0" noProof="0" dirty="0">
-              <a:ln>
-                <a:noFill/>
-              </a:ln>
-              <a:solidFill>
-                <a:srgbClr val="888B8D">
-                  <a:lumMod val="50000"/>
-                </a:srgbClr>
-              </a:solidFill>
-              <a:effectLst/>
-              <a:uLnTx/>
-              <a:uFillTx/>
-            </a:endParaRPr>
+            <a:r>
+              <a:rPr kumimoji="0" lang="en-US" sz="1050" b="0" i="0" u="none" strike="noStrike" kern="0" cap="none" spc="0" normalizeH="0" baseline="0" noProof="0" dirty="0">
+                <a:ln>
+                  <a:noFill/>
+                </a:ln>
+                <a:effectLst/>
+                <a:uLnTx/>
+                <a:uFillTx/>
+              </a:rPr>
+              <a:t/>
+            </a:r>
+          </a:p>
+          <a:p>
+            <a:r>
+              <a:rPr kumimoji="0" lang="en-US" sz="1050" b="0" i="0" u="none" strike="noStrike" kern="0" cap="none" spc="0" normalizeH="0" baseline="0" noProof="0" dirty="0">
+                <a:ln>
+                  <a:noFill/>
+                </a:ln>
+                <a:effectLst/>
+                <a:uLnTx/>
+                <a:uFillTx/>
+              </a:rPr>
+              <a:t/>
+            </a:r>
           </a:p>
         </p:txBody>
       </p:sp>
@@ -21759,37 +21026,8 @@
           <a:p>
             <a:r>
               <a:rPr lang="en-GB" dirty="0"/>
-              <a:t>Der </a:t>
+              <a:t>Der Weg – die Entwicklung einer Digitalstrategie</a:t>
             </a:r>
-            <a:r>
-              <a:rPr lang="en-GB" dirty="0" smtClean="0"/>
-              <a:t>Weg </a:t>
-            </a:r>
-            <a:r>
-              <a:rPr lang="en-GB" dirty="0"/>
-              <a:t>– </a:t>
-            </a:r>
-            <a:r>
-              <a:rPr lang="en-GB" dirty="0" smtClean="0"/>
-              <a:t>Entwicklung einer </a:t>
-            </a:r>
-            <a:r>
-              <a:rPr lang="en-GB" dirty="0"/>
-              <a:t>D</a:t>
-            </a:r>
-            <a:r>
-              <a:rPr lang="en-GB" dirty="0" smtClean="0"/>
-              <a:t>igitalen </a:t>
-            </a:r>
-            <a:r>
-              <a:rPr lang="en-GB" dirty="0"/>
-              <a:t>S</a:t>
-            </a:r>
-            <a:r>
-              <a:rPr lang="en-GB" dirty="0" smtClean="0"/>
-              <a:t>trategie</a:t>
-            </a:r>
-            <a:endParaRPr lang="en-GB" dirty="0"/>
           </a:p>
         </p:txBody>
       </p:sp>

</xml_diff>